<commit_message>
Remove outdated HTML slides for architecture, MLFQ structure, preemption, performance, and multi-seed validation from the midterm report figures.
</commit_message>
<xml_diff>
--- a/05-midterm-report/figures/fig-5-experiment-results.pptx
+++ b/05-midterm-report/figures/fig-5-experiment-results.pptx
@@ -196,13 +196,13 @@
                   <c:v>2572</c:v>
                 </c:pt>
                 <c:pt idx="1">
-                  <c:v>2826</c:v>
+                  <c:v>2677</c:v>
                 </c:pt>
                 <c:pt idx="2">
                   <c:v>2572</c:v>
                 </c:pt>
                 <c:pt idx="3">
-                  <c:v>2819</c:v>
+                  <c:v>2476</c:v>
                 </c:pt>
               </c:numCache>
             </c:numRef>
@@ -443,16 +443,16 @@
                 <c:formatCode>General</c:formatCode>
                 <c:ptCount val="4"/>
                 <c:pt idx="0">
-                  <c:v>849</c:v>
+                  <c:v>429</c:v>
                 </c:pt>
                 <c:pt idx="1">
-                  <c:v>2103</c:v>
+                  <c:v>1817</c:v>
                 </c:pt>
                 <c:pt idx="2">
-                  <c:v>3431</c:v>
+                  <c:v>3116</c:v>
                 </c:pt>
                 <c:pt idx="3">
-                  <c:v>4894</c:v>
+                  <c:v>4543</c:v>
                 </c:pt>
               </c:numCache>
             </c:numRef>
@@ -680,7 +680,7 @@
                 <c:formatCode>General</c:formatCode>
                 <c:ptCount val="1"/>
                 <c:pt idx="0">
-                  <c:v>651</c:v>
+                  <c:v>634</c:v>
                 </c:pt>
               </c:numCache>
             </c:numRef>
@@ -751,7 +751,7 @@
                 <c:formatCode>General</c:formatCode>
                 <c:ptCount val="1"/>
                 <c:pt idx="0">
-                  <c:v>170</c:v>
+                  <c:v>172</c:v>
                 </c:pt>
               </c:numCache>
             </c:numRef>
@@ -1779,7 +1779,7 @@
         </p:nvSpPr>
         <p:spPr>
           <a:xfrm>
-            <a:off x="822960" y="1430465"/>
+            <a:off x="822960" y="1500759"/>
             <a:ext cx="3200400" cy="13716"/>
           </a:xfrm>
           <a:prstGeom prst="rect">
@@ -1804,7 +1804,7 @@
         </p:nvSpPr>
         <p:spPr>
           <a:xfrm>
-            <a:off x="2926080" y="1229297"/>
+            <a:off x="2926080" y="1299591"/>
             <a:ext cx="1188720" cy="182880"/>
           </a:xfrm>
           <a:prstGeom prst="rect">
@@ -1829,7 +1829,7 @@
                 <a:ea typeface="맑은 고딕" pitchFamily="34" charset="-122"/>
                 <a:cs typeface="맑은 고딕" pitchFamily="34" charset="-120"/>
               </a:rPr>
-              <a:t>avg: 2,697ms</a:t>
+              <a:t>avg: 2,574ms</a:t>
             </a:r>
             <a:endParaRPr lang="en-US" sz="700" dirty="0"/>
           </a:p>
@@ -1923,7 +1923,7 @@
                 <a:ea typeface="맑은 고딕" pitchFamily="34" charset="-122"/>
                 <a:cs typeface="맑은 고딕" pitchFamily="34" charset="-120"/>
               </a:rPr>
-              <a:t>(c) MLFQ 선점형 효과 — 짧은 요청 대기시간 (10회 반복)</a:t>
+              <a:t>(c) MLFQ 선점형 효과 — 짧은 요청 대기시간 (5회 반복)</a:t>
             </a:r>
             <a:endParaRPr lang="en-US" sz="1100" dirty="0"/>
           </a:p>
@@ -1978,7 +1978,7 @@
                 <a:ea typeface="맑은 고딕" pitchFamily="34" charset="-122"/>
                 <a:cs typeface="맑은 고딕" pitchFamily="34" charset="-120"/>
               </a:rPr>
-              <a:t>약 74% 감소</a:t>
+              <a:t>약 73% 감소</a:t>
             </a:r>
             <a:endParaRPr lang="en-US" sz="1100" dirty="0"/>
           </a:p>
@@ -2088,7 +2088,7 @@
                 <a:ea typeface="맑은 고딕" pitchFamily="34" charset="-122"/>
                 <a:cs typeface="맑은 고딕" pitchFamily="34" charset="-120"/>
               </a:rPr>
-              <a:t>URGENT 요청 56% 빠름
+              <a:t>URGENT 약 42ms (거의 즉시)
 </a:t>
             </a:r>
             <a:pPr indent="0" marL="0">
@@ -2117,7 +2117,7 @@
                 <a:ea typeface="맑은 고딕" pitchFamily="34" charset="-122"/>
                 <a:cs typeface="맑은 고딕" pitchFamily="34" charset="-120"/>
               </a:rPr>
-              <a:t>Enterprise vs Free 5.8배 차이
+              <a:t>Enterprise vs Free 약 10배 차이
 </a:t>
             </a:r>
             <a:pPr indent="0" marL="0">
@@ -2161,7 +2161,7 @@
                 <a:ea typeface="맑은 고딕" pitchFamily="34" charset="-122"/>
                 <a:cs typeface="맑은 고딕" pitchFamily="34" charset="-120"/>
               </a:rPr>
-              <a:t>짧은 요청 약 74% 개선</a:t>
+              <a:t>짧은 요청 약 73% 개선</a:t>
             </a:r>
             <a:endParaRPr lang="en-US" sz="1200" dirty="0"/>
           </a:p>

</xml_diff>

<commit_message>
Add package.json for LLM scheduler project with scripts and dependencies
</commit_message>
<xml_diff>
--- a/05-midterm-report/figures/fig-5-experiment-results.pptx
+++ b/05-midterm-report/figures/fig-5-experiment-results.pptx
@@ -680,7 +680,7 @@
                 <c:formatCode>General</c:formatCode>
                 <c:ptCount val="1"/>
                 <c:pt idx="0">
-                  <c:v>634</c:v>
+                  <c:v>635</c:v>
                 </c:pt>
               </c:numCache>
             </c:numRef>
@@ -751,7 +751,7 @@
                 <c:formatCode>General</c:formatCode>
                 <c:ptCount val="1"/>
                 <c:pt idx="0">
-                  <c:v>172</c:v>
+                  <c:v>170</c:v>
                 </c:pt>
               </c:numCache>
             </c:numRef>

</xml_diff>